<commit_message>
Add plagiarism report for A25GM13
</commit_message>
<xml_diff>
--- a/Thesis Book/pre-defence/A25GM13 Presentation Slide.pptx
+++ b/Thesis Book/pre-defence/A25GM13 Presentation Slide.pptx
@@ -12207,8 +12207,8 @@
           </a:p>
         </p:txBody>
       </p:sp>
-      <mc:AlternateContent xmlns:mc="http://schemas.openxmlformats.org/markup-compatibility/2006">
-        <mc:Choice xmlns:a14="http://schemas.microsoft.com/office/drawing/2010/main" Requires="a14">
+      <mc:AlternateContent xmlns:mc="http://schemas.openxmlformats.org/markup-compatibility/2006" xmlns:a14="http://schemas.microsoft.com/office/drawing/2010/main">
+        <mc:Choice Requires="a14">
           <p:sp>
             <p:nvSpPr>
               <p:cNvPr id="3" name="Google Shape;1195;p86"/>
@@ -12431,7 +12431,7 @@
             </p:txBody>
           </p:sp>
         </mc:Choice>
-        <mc:Fallback>
+        <mc:Fallback xmlns="">
           <p:sp>
             <p:nvSpPr>
               <p:cNvPr id="3" name="Google Shape;1195;p86"/>
@@ -12587,8 +12587,8 @@
           </a:p>
         </p:txBody>
       </p:sp>
-      <mc:AlternateContent xmlns:mc="http://schemas.openxmlformats.org/markup-compatibility/2006">
-        <mc:Choice xmlns:a14="http://schemas.microsoft.com/office/drawing/2010/main" Requires="a14">
+      <mc:AlternateContent xmlns:mc="http://schemas.openxmlformats.org/markup-compatibility/2006" xmlns:a14="http://schemas.microsoft.com/office/drawing/2010/main">
+        <mc:Choice Requires="a14">
           <p:sp>
             <p:nvSpPr>
               <p:cNvPr id="3" name="Google Shape;1195;p86"/>
@@ -12779,7 +12779,7 @@
             </p:txBody>
           </p:sp>
         </mc:Choice>
-        <mc:Fallback>
+        <mc:Fallback xmlns="">
           <p:sp>
             <p:nvSpPr>
               <p:cNvPr id="3" name="Google Shape;1195;p86"/>
@@ -12823,8 +12823,8 @@
           </p:sp>
         </mc:Fallback>
       </mc:AlternateContent>
-      <mc:AlternateContent xmlns:mc="http://schemas.openxmlformats.org/markup-compatibility/2006">
-        <mc:Choice xmlns:a14="http://schemas.microsoft.com/office/drawing/2010/main" Requires="a14">
+      <mc:AlternateContent xmlns:mc="http://schemas.openxmlformats.org/markup-compatibility/2006" xmlns:a14="http://schemas.microsoft.com/office/drawing/2010/main">
+        <mc:Choice Requires="a14">
           <p:sp>
             <p:nvSpPr>
               <p:cNvPr id="2" name="Google Shape;1195;p86">
@@ -13012,7 +13012,7 @@
             </p:txBody>
           </p:sp>
         </mc:Choice>
-        <mc:Fallback>
+        <mc:Fallback xmlns="">
           <p:sp>
             <p:nvSpPr>
               <p:cNvPr id="2" name="Google Shape;1195;p86">
@@ -14535,8 +14535,8 @@
           </a:p>
         </p:txBody>
       </p:sp>
-      <mc:AlternateContent xmlns:mc="http://schemas.openxmlformats.org/markup-compatibility/2006">
-        <mc:Choice xmlns:a14="http://schemas.microsoft.com/office/drawing/2010/main" Requires="a14">
+      <mc:AlternateContent xmlns:mc="http://schemas.openxmlformats.org/markup-compatibility/2006" xmlns:a14="http://schemas.microsoft.com/office/drawing/2010/main">
+        <mc:Choice Requires="a14">
           <p:sp>
             <p:nvSpPr>
               <p:cNvPr id="3" name="Google Shape;1195;p86"/>
@@ -14674,7 +14674,7 @@
             </p:txBody>
           </p:sp>
         </mc:Choice>
-        <mc:Fallback>
+        <mc:Fallback xmlns="">
           <p:sp>
             <p:nvSpPr>
               <p:cNvPr id="3" name="Google Shape;1195;p86"/>
@@ -15814,11 +15814,11 @@
               <a:buChar char="Ø"/>
             </a:pPr>
             <a:r>
-              <a:rPr lang="en-US" b="1" dirty="0"/>
-              <a:t>MTCMOS paper(2019)</a:t>
+              <a:rPr lang="en-US" b="1"/>
+              <a:t>My Propose Design</a:t>
             </a:r>
             <a:r>
-              <a:rPr lang="en-US" dirty="0"/>
+              <a:rPr lang="en-US"/>
               <a:t>:</a:t>
             </a:r>
           </a:p>
@@ -15828,8 +15828,12 @@
               <a:buChar char="•"/>
             </a:pPr>
             <a:r>
+              <a:rPr lang="en-US"/>
+              <a:t>Propagation </a:t>
+            </a:r>
+            <a:r>
               <a:rPr lang="en-US" dirty="0"/>
-              <a:t>Propagation Delay : 336 </a:t>
+              <a:t>Delay : 336 </a:t>
             </a:r>
             <a:r>
               <a:rPr lang="en-US" dirty="0" err="1"/>
@@ -24673,8 +24677,8 @@
           </p:txBody>
         </p:sp>
       </p:grpSp>
-      <mc:AlternateContent xmlns:mc="http://schemas.openxmlformats.org/markup-compatibility/2006">
-        <mc:Choice xmlns:a14="http://schemas.microsoft.com/office/drawing/2010/main" Requires="a14">
+      <mc:AlternateContent xmlns:mc="http://schemas.openxmlformats.org/markup-compatibility/2006" xmlns:a14="http://schemas.microsoft.com/office/drawing/2010/main">
+        <mc:Choice Requires="a14">
           <p:graphicFrame>
             <p:nvGraphicFramePr>
               <p:cNvPr id="2" name="Table 1">
@@ -25003,7 +25007,7 @@
             </a:graphic>
           </p:graphicFrame>
         </mc:Choice>
-        <mc:Fallback>
+        <mc:Fallback xmlns="">
           <p:graphicFrame>
             <p:nvGraphicFramePr>
               <p:cNvPr id="2" name="Table 1">

</xml_diff>